<commit_message>
Apply first Codex review to cybersecurity risk PPT (re-review pending)
Co-Authored-By: Claude Opus 5.5 <noreply@anthropic.com>
Claude-Session: https://claude.ai/code/session_01SrYrUrF1fXS2b11iX2y7MR
</commit_message>
<xml_diff>
--- a/ppt/cybersecurity_risk/사이버보안_위험관리_검토전초안.pptx
+++ b/ppt/cybersecurity_risk/사이버보안_위험관리_검토전초안.pptx
@@ -111,7 +111,7 @@
   <p:extLst>
     <p:ext uri="{521415D9-36F7-43E2-AB2F-B90AF26B5E84}">
       <p14:sectionLst xmlns:p14="http://schemas.microsoft.com/office/powerpoint/2010/main">
-        <p14:section name="01 사이버보안 위험관리" id="{b78dd683-99a6-848d-333b-34b5b11fd714}">
+        <p14:section name="01 사이버보안 위험관리" id="{a369a2f6-66fc-ec1f-7256-4ed61a065c80}">
           <p14:sldIdLst>
             <p14:sldId id="256"/>
             <p14:sldId id="257"/>
@@ -524,7 +524,7 @@
           <a:p>
             <a:r>
               <a:rPr lang="en-US" dirty="0"/>
-              <a:t>이번 섹션은 보안 위협이 환자 안전 위해로 이어지는 경로를 위험관리 체계 안에서 어떻게 다룰지 정리한다. 핵심 과제는 두 가지다. 첫째, 안전 위험과 보안 위험을 함께 평가하는 매트릭스를 설계하는 것이다. 둘째, 의도적 공격의 발생 확률을 산정하기 어려운 상황에서 인증기관(Notified Body, NB)이 수용할 수 있는 위험 허용 논리를 세우는 것이다.</a:t>
+              <a:t>이번 섹션은 보안 위협이 환자 안전 위해로 이어지는 경로를 위험관리 체계 안에서 다루는 방법을 정리한다. 핵심 과제 두 가지를 제시한다. 첫째, 안전 위험과 보안 위험을 함께 평가하는 매트릭스를 설계한다. 둘째, 의도적 공격의 발생 확률을 산정하기 어려운 상황에서 인증기관(Notified Body, NB)이 수용할 수 있는 위험 허용 논리를 세운다.</a:t>
             </a:r>
             <a:endParaRPr lang="en-US" dirty="0"/>
           </a:p>
@@ -612,7 +612,7 @@
           <a:p>
             <a:r>
               <a:rPr lang="en-US" dirty="0"/>
-              <a:t>ISO 14971 자체는 보안 위험 평가 방법을 자세히 다루지 않는다. 그래서 AAMI TIR57이 ISO 14971의 구조를 그대로 가져와 보안 위험관리에 적용하는 방법을 제시한다(후속 규격: ANSI/AAMI SW96:2023). MDCG 2019-16 부록 I은 두 프로세스가 서로 결과를 주고받아야 한다는 관계를 보여준다. 유럽 심사에서 TIR57은 정합 규격(harmonised standard)이 아니지만, 최신 기술 수준(state of the art)을 보여주는 근거로 흔히 인용된다.</a:t>
+              <a:t>MDCG 2019-16 §3.2는 보안 위험을 위험관리 프로세스의 범위 안에 두므로 별도 프로세스가 필수는 아니라고 설명한다. 다만 보안 위험에는 위협 모델링 같은 보안 특화 방법을 쓴다. 두 활동은 결과를 서로 주고받는다. 예를 들어 개인정보 노출을 막으려고 화면을 가리는 보안 통제는 생체 신호를 표시하는 기기에서는 안전 문제가 된다. 이 관계는 MDCG 2019-16 부록 IV와 그림 6에 도식으로 나와 있다. ISO 14971은 위해·심각도 등의 용어와 위험관리 프로세스를 규정하고, 위험 허용 기준은 제조사가 정하도록 요구한다. AAMI TIR57은 ISO 14971의 틀 안에서 보안 위험관리를 수행하는 지침이다. 후속 문서인 ANSI/AAMI SW96:2023은 TIR57을 바탕으로 수명주기 전반의 보안 위험관리 요구사항을 제시한다. TIR57은 EU 정합 규격(harmonised standard)이 아니므로, 적용 방법의 적절성을 설명하는 참고 근거로 활용한다.</a:t>
             </a:r>
             <a:endParaRPr lang="en-US" dirty="0"/>
           </a:p>
@@ -700,7 +700,7 @@
           <a:p>
             <a:r>
               <a:rPr lang="en-US" dirty="0"/>
-              <a:t>안전 매트릭스의 확률 축을 공격 가능성 축으로 바꾸는 것이 핵심이다. 우발적 고장은 확률로 평가하지만, 의도적 공격은 확률을 신뢰성 있게 산정하기 어렵다. 그래서 같은 매트릭스 틀을 유지하면서 축만 정성적 공격 가능성으로 바꾼다. 축의 등급 수와 판정 칸은 위험관리 계획서에서 미리 정하고, 평가 후에 바꾸지 않는다.</a:t>
+              <a:t>공격 가능성은 위해 발생 확률과 같지 않다. 공격이 성공해도 위해상황과 위해로 이어지는 경로를 따로 분석해야 한다. 그래서 공격 가능성은 위해상황이 생길 가능성을 판단하는 입력으로 쓴다. ISO 14971:2019 5.5항은 위해 발생 확률을 추정할 수 없으면 가능한 결과를 나열해 위험평가와 위험 통제에 쓰도록 한다. 따라서 확률을 추정하지 않은 사유를 기록하고, 심각도와 통제 근거를 바탕으로 미리 정한 기준에 따라 판정한다. "추가 통제 검토" 칸은 최종 판정이 아니므로, 검토 후 허용 또는 허용 불가로 처분하는 규칙도 계획서에 둔다. 추적 예시는 다음과 같다. 위협 시나리오(무선 인터페이스로 펌프 설정 변조) → 사건 연쇄 → 위해상황(과다 투여 설정) → 위해(약물 과다 투여) → 통제(명령 인증·무결성 검증) → 검증 결과 → 잔여 위험 판정.</a:t>
             </a:r>
             <a:endParaRPr lang="en-US" dirty="0"/>
           </a:p>
@@ -788,7 +788,7 @@
           <a:p>
             <a:r>
               <a:rPr lang="en-US" dirty="0"/>
-              <a:t>확률을 억지로 숫자로 만들면 심사에서 근거를 묻는 질문에 답하기 어렵다. 공격 잠재력 요소는 공격자가 실제로 들여야 하는 시간, 지식, 장비를 기준으로 하므로 재현 가능하고 설명하기 쉽다. 점수가 높을수록 공격에 더 많은 자원이 필요하므로 공격 가능성은 낮아진다. CVSS는 취약점의 기술적 심각도 지표이므로 환자 위해 심각도를 대신하지 못한다. 어떤 체계를 쓰든 점수와 등급 변환 기준을 위험관리 계획서에 고정해 두어야 한다.</a:t>
+              <a:t>MDCG 2019-16 §3.4는 보안 시나리오의 가능성 판단을 CVSS 같은 구조화된 점수 체계로 뒷받침할 수 있다고 설명한다. 공격 잠재력 요소는 공격자가 실제로 들여야 하는 시간, 지식, 장비를 기준으로 하므로 재현하고 설명하기 쉽다. CVSS v4.0을 쓰면 공격 요구조건(AT) 같은 바뀐 지표를 반영한다. 어떤 체계를 쓰든 점수와 등급 변환 기준을 평가 전에 고정한다.</a:t>
             </a:r>
             <a:endParaRPr lang="en-US" dirty="0"/>
           </a:p>
@@ -876,7 +876,7 @@
           <a:p>
             <a:r>
               <a:rPr lang="en-US" dirty="0"/>
-              <a:t>NB가 가장 먼저 확인하는 것은 기준을 평가 결과에 맞춰 바꾸지 않았는가이다. 그래서 기준을 계획서에 미리 고정하는 것이 출발점이다. 다음으로 확률을 낮게 잡아 위험을 줄였다는 인상을 피하기 위해 최악 가정에서 시작한다. 통제의 효과는 침투 시험 같은 객관적 증거로 보이고, 공격 가능성은 시간이 지나면 변하므로 시판 후 감시 계획으로 논리를 닫는다. EU MDR은 위험을 가능한 한 줄일 것(as far as possible)을 요구하므로(EN ISO 14971:2019+A11:2021 부속서 ZA 참조), 경제성만을 이유로 통제를 생략했다는 인상을 주지 않아야 한다.</a:t>
+              <a:t>NB가 확인할 핵심 사항은 기준을 평가 결과에 맞춰 바꾸지 않았는지이다. 그래서 기준을 계획서에 미리 고정하는 것이 출발점이다. 최악 결과 가정은 위해 경로와 임상적 결과를 명시할 때 의미가 있다. 침투 시험에서 문제가 발견되지 않았다는 사실만으로 모든 통제의 효과를 입증하지는 못하므로, 여러 검증 방법과 시험 범위를 함께 제시한다. SBOM은 그 자체로 감시 활동이 아니라 감시의 입력이다. 취약점 접수 책임자, 재평가 기한, 패치 검증, 지원 종료 계획을 함께 정한다. EU MDR 부속서 I 2항은 이익-위험 비율에 악영향을 주지 않는 범위에서 위험을 가능한 한(as far as possible) 줄이도록 요구한다. 따라서 검토한 통제 대안, 채택 여부, 더 줄일 수 없는 근거를 기록한다. MDCG 2019-16 §3.5에 따르면 보안 위험마다 이익-위험 분석을 하지 않고, 보안 관련 위험원을 포함한 안전 위험평가를 바탕으로 전체 이익-위험 분석을 수행한다.</a:t>
             </a:r>
             <a:endParaRPr lang="en-US" dirty="0"/>
           </a:p>
@@ -1604,7 +1604,7 @@
                   <a:srgbClr val="44546A"/>
                 </a:solidFill>
               </a:rPr>
-              <a:t>Security Risk Management — Safety와 Security의 통합 평가</a:t>
+              <a:t>Security Risk Management — 안전(safety)과 보안(security)의 통합 평가</a:t>
             </a:r>
             <a:endParaRPr lang="en-US" sz="2000" dirty="0"/>
           </a:p>
@@ -1688,11 +1688,11 @@
         <p:spPr>
           <a:xfrm>
             <a:off x="457200" y="1188720"/>
-            <a:ext cx="1005840" cy="914400"/>
+            <a:ext cx="1005840" cy="1051560"/>
           </a:xfrm>
           <a:prstGeom prst="roundRect">
             <a:avLst>
-              <a:gd name="adj" fmla="val 12000"/>
+              <a:gd name="adj" fmla="val 10909"/>
             </a:avLst>
           </a:prstGeom>
           <a:solidFill>
@@ -1732,11 +1732,11 @@
         <p:spPr>
           <a:xfrm>
             <a:off x="1600200" y="1188720"/>
-            <a:ext cx="10131552" cy="914400"/>
+            <a:ext cx="10131552" cy="1051560"/>
           </a:xfrm>
           <a:prstGeom prst="roundRect">
             <a:avLst>
-              <a:gd name="adj" fmla="val 12000"/>
+              <a:gd name="adj" fmla="val 10435"/>
             </a:avLst>
           </a:prstGeom>
           <a:solidFill>
@@ -1761,7 +1761,7 @@
                   <a:srgbClr val="262626"/>
                 </a:solidFill>
               </a:rPr>
-              <a:t>안전 위험관리(safety risk management)와 보안 위험관리(security risk management)를 별도 프로세스로 운영하되, 보안 위험이 위해(harm)로 이어질 수 있으면 안전 위험관리로 넘겨 함께 평가한다.</a:t>
+              <a:t>보안 위험에는 보안 특화 분석 방법을 쓰되, 하나의 위험관리 체계 안에서 안전 위험관리와 양방향으로 연계한다. 보안 위험이 안전이나 유효성에 영향을 주면 안전 위험평가에 포함한다.</a:t>
             </a:r>
             <a:endParaRPr lang="en-US" sz="1600" dirty="0"/>
           </a:p>
@@ -1819,7 +1819,7 @@
                   <a:srgbClr val="FFFFFF"/>
                 </a:solidFill>
               </a:rPr>
-              <a:t>AAMI TIR57:2016/(R)2019</a:t>
+              <a:t>AAMI TIR57:2016/(R)2023</a:t>
             </a:r>
             <a:endParaRPr lang="en-US" sz="1400" dirty="0"/>
           </a:p>
@@ -1999,7 +1999,7 @@
                   <a:srgbClr val="262626"/>
                 </a:solidFill>
               </a:rPr>
-              <a:t>보안 위험 평가</a:t>
+              <a:t>보안 위험평가</a:t>
             </a:r>
             <a:endParaRPr lang="en-US" sz="1400" dirty="0"/>
           </a:p>
@@ -2237,7 +2237,7 @@
                   <a:srgbClr val="262626"/>
                 </a:solidFill>
               </a:rPr>
-              <a:t>위해 상황(hazardous situation) 분석</a:t>
+              <a:t>위해상황(hazardous situation) 분석</a:t>
             </a:r>
             <a:endParaRPr lang="en-US" sz="1400" dirty="0"/>
           </a:p>
@@ -2305,7 +2305,7 @@
                   <a:srgbClr val="262626"/>
                 </a:solidFill>
               </a:rPr>
-              <a:t>위험 평가</a:t>
+              <a:t>위험평가</a:t>
             </a:r>
             <a:endParaRPr lang="en-US" sz="1400" dirty="0"/>
           </a:p>
@@ -2431,7 +2431,7 @@
                   <a:srgbClr val="FFFFFF"/>
                 </a:solidFill>
               </a:rPr>
-              <a:t>부록 I · 상호 연계</a:t>
+              <a:t>§3.2 · 부록 IV</a:t>
             </a:r>
             <a:endParaRPr lang="en-US" sz="1300" dirty="0"/>
           </a:p>
@@ -2491,7 +2491,7 @@
                   <a:srgbClr val="262626"/>
                 </a:solidFill>
               </a:rPr>
-              <a:t>안전에 영향을 주는</a:t>
+              <a:t>안전·유효성 영향이 있으면</a:t>
             </a:r>
             <a:endParaRPr lang="en-US" sz="1200" dirty="0"/>
           </a:p>
@@ -2505,7 +2505,7 @@
                   <a:srgbClr val="262626"/>
                 </a:solidFill>
               </a:rPr>
-              <a:t>보안 위험 전달</a:t>
+              <a:t>안전 위험평가에 포함</a:t>
             </a:r>
             <a:endParaRPr lang="en-US" sz="1200" dirty="0"/>
           </a:p>
@@ -2543,8 +2543,8 @@
         </p:nvSpPr>
         <p:spPr>
           <a:xfrm>
-            <a:off x="4937760" y="5632704"/>
-            <a:ext cx="2313432" cy="457200"/>
+            <a:off x="4937760" y="5010912"/>
+            <a:ext cx="2313432" cy="475488"/>
           </a:xfrm>
           <a:prstGeom prst="rect">
             <a:avLst/>
@@ -2553,7 +2553,7 @@
           <a:ln/>
         </p:spPr>
         <p:txBody>
-          <a:bodyPr wrap="square" lIns="0" tIns="0" rIns="0" bIns="0" rtlCol="0" anchor="t"/>
+          <a:bodyPr wrap="square" lIns="0" tIns="0" rIns="0" bIns="0" rtlCol="0" anchor="b"/>
           <a:lstStyle/>
           <a:p>
             <a:pPr algn="ctr" indent="0" marL="0">
@@ -2565,10 +2565,24 @@
                   <a:srgbClr val="262626"/>
                 </a:solidFill>
               </a:rPr>
-              <a:t>위험 통제의 보안 영향 전달</a:t>
+              <a:t>안전 통제의 보안 영향은</a:t>
             </a:r>
             <a:endParaRPr lang="en-US" sz="1200" dirty="0"/>
           </a:p>
+          <a:p>
+            <a:pPr algn="ctr" indent="0" marL="0">
+              <a:buNone/>
+            </a:pPr>
+            <a:r>
+              <a:rPr lang="en-US" sz="1200" dirty="0">
+                <a:solidFill>
+                  <a:srgbClr val="262626"/>
+                </a:solidFill>
+              </a:rPr>
+              <a:t>보안 위험분석에 포함</a:t>
+            </a:r>
+            <a:endParaRPr lang="en-US" sz="1200" dirty="0"/>
+          </a:p>
         </p:txBody>
       </p:sp>
       <p:sp>
@@ -2579,8 +2593,8 @@
         </p:nvSpPr>
         <p:spPr>
           <a:xfrm>
-            <a:off x="457200" y="6172200"/>
-            <a:ext cx="10607040" cy="320040"/>
+            <a:off x="457200" y="5989320"/>
+            <a:ext cx="10607040" cy="502920"/>
           </a:xfrm>
           <a:prstGeom prst="rect">
             <a:avLst/>
@@ -2589,7 +2603,7 @@
           <a:ln/>
         </p:spPr>
         <p:txBody>
-          <a:bodyPr wrap="square" lIns="0" tIns="0" rIns="0" bIns="0" rtlCol="0" anchor="ctr"/>
+          <a:bodyPr wrap="square" lIns="0" tIns="0" rIns="0" bIns="0" rtlCol="0" anchor="t"/>
           <a:lstStyle/>
           <a:p>
             <a:pPr indent="0" marL="0">
@@ -2601,7 +2615,7 @@
                   <a:srgbClr val="7F7F7F"/>
                 </a:solidFill>
               </a:rPr>
-              <a:t>보조 참조: ISO/TR 24971:2020 부록 F(보안 관련 위험관리 지침), EU MDR 부속서 I 17.2·17.4·18.8항(정보보안·무단 접근 방지 요구사항)</a:t>
+              <a:t>보조 참조: ISO/TR 24971:2020 부록 F(보안 관련 위험관리 지침) · EU MDR 부속서 I 17.2항(정보보안을 포함한 소프트웨어 수명주기 개발), 17.4항(하드웨어·IT 네트워크·IT 보안 최소 요구사항), 18.8항(능동기기의 무단 접근 방지)</a:t>
             </a:r>
             <a:endParaRPr lang="en-US" sz="1100" dirty="0"/>
           </a:p>
@@ -2733,11 +2747,11 @@
         <p:spPr>
           <a:xfrm>
             <a:off x="457200" y="1188720"/>
-            <a:ext cx="1005840" cy="914400"/>
+            <a:ext cx="1005840" cy="1051560"/>
           </a:xfrm>
           <a:prstGeom prst="roundRect">
             <a:avLst>
-              <a:gd name="adj" fmla="val 12000"/>
+              <a:gd name="adj" fmla="val 10909"/>
             </a:avLst>
           </a:prstGeom>
           <a:solidFill>
@@ -2777,11 +2791,11 @@
         <p:spPr>
           <a:xfrm>
             <a:off x="1600200" y="1188720"/>
-            <a:ext cx="10131552" cy="914400"/>
+            <a:ext cx="10131552" cy="1051560"/>
           </a:xfrm>
           <a:prstGeom prst="roundRect">
             <a:avLst>
-              <a:gd name="adj" fmla="val 12000"/>
+              <a:gd name="adj" fmla="val 10435"/>
             </a:avLst>
           </a:prstGeom>
           <a:solidFill>
@@ -2806,7 +2820,7 @@
                   <a:srgbClr val="262626"/>
                 </a:solidFill>
               </a:rPr>
-              <a:t>보안 위험을 먼저 공격 가능성(exploitability)과 영향(impact)으로 평가하고, 환자 안전에 영향을 주는 항목만 안전 매트릭스로 넘겨 위해의 심각도(severity)로 다시 평가한다.</a:t>
+              <a:t>보안 시나리오를 공격 가능성(exploitability)과 CIA 영향으로 먼저 평가한다. 안전·유효성에 영향을 주는 항목은 위해 경로를 분석해 공격 가능성과 위해 심각도(severity)의 조합으로 다시 판정한다.</a:t>
             </a:r>
             <a:endParaRPr lang="en-US" sz="1600" dirty="0"/>
           </a:p>
@@ -2864,7 +2878,7 @@
                   <a:srgbClr val="262626"/>
                 </a:solidFill>
               </a:rPr>
-              <a:t>공격 가능성 × 기밀성·무결성·가용성(CIA) 영향</a:t>
+              <a:t>공격 가능성과 기밀성·무결성·가용성(CIA) 영향의 조합</a:t>
             </a:r>
             <a:endParaRPr lang="en-US" sz="1400" dirty="0"/>
           </a:p>
@@ -2930,7 +2944,7 @@
                   <a:srgbClr val="262626"/>
                 </a:solidFill>
               </a:rPr>
-              <a:t>환자 안전에</a:t>
+              <a:t>안전 또는 유효성에</a:t>
             </a:r>
             <a:endParaRPr lang="en-US" sz="1300" dirty="0"/>
           </a:p>
@@ -3018,12 +3032,12 @@
         </p:nvSpPr>
         <p:spPr>
           <a:xfrm>
-            <a:off x="3794760" y="3840480"/>
-            <a:ext cx="1600200" cy="731520"/>
+            <a:off x="3794760" y="3776472"/>
+            <a:ext cx="1600200" cy="868680"/>
           </a:xfrm>
           <a:prstGeom prst="roundRect">
             <a:avLst>
-              <a:gd name="adj" fmla="val 12500"/>
+              <a:gd name="adj" fmla="val 10526"/>
             </a:avLst>
           </a:prstGeom>
           <a:solidFill>
@@ -3048,7 +3062,7 @@
                   <a:srgbClr val="262626"/>
                 </a:solidFill>
               </a:rPr>
-              <a:t>보안 위험으로만 관리함</a:t>
+              <a:t>보안 위험으로 관리함</a:t>
             </a:r>
             <a:endParaRPr lang="en-US" sz="1200" dirty="0"/>
           </a:p>
@@ -3062,7 +3076,21 @@
                   <a:srgbClr val="262626"/>
                 </a:solidFill>
               </a:rPr>
-              <a:t>(데이터 보호 등)</a:t>
+              <a:t>(위해 연결 여부는</a:t>
+            </a:r>
+            <a:endParaRPr lang="en-US" sz="1200" dirty="0"/>
+          </a:p>
+          <a:p>
+            <a:pPr algn="ctr" indent="0" marL="0">
+              <a:buNone/>
+            </a:pPr>
+            <a:r>
+              <a:rPr lang="en-US" sz="1200" dirty="0">
+                <a:solidFill>
+                  <a:srgbClr val="262626"/>
+                </a:solidFill>
+              </a:rPr>
+              <a:t>개별 판단함)</a:t>
             </a:r>
             <a:endParaRPr lang="en-US" sz="1200" dirty="0"/>
           </a:p>
@@ -3180,7 +3208,7 @@
                   <a:srgbClr val="FFFFFF"/>
                 </a:solidFill>
               </a:rPr>
-              <a:t>공격 가능성 × 위해 심각도 → 허용 여부 판정</a:t>
+              <a:t>위해 경로 분석 후 공격 가능성·심각도 조합으로 판정</a:t>
             </a:r>
             <a:endParaRPr lang="en-US" sz="1400" dirty="0"/>
           </a:p>
@@ -4870,8 +4898,8 @@
         </p:nvSpPr>
         <p:spPr>
           <a:xfrm>
-            <a:off x="5852160" y="5852160"/>
-            <a:ext cx="5879592" cy="320040"/>
+            <a:off x="5852160" y="5760720"/>
+            <a:ext cx="5879592" cy="548640"/>
           </a:xfrm>
           <a:prstGeom prst="rect">
             <a:avLst/>
@@ -4880,7 +4908,7 @@
           <a:ln/>
         </p:spPr>
         <p:txBody>
-          <a:bodyPr wrap="square" lIns="0" tIns="0" rIns="0" bIns="0" rtlCol="0" anchor="ctr"/>
+          <a:bodyPr wrap="square" lIns="0" tIns="0" rIns="0" bIns="0" rtlCol="0" anchor="t"/>
           <a:lstStyle/>
           <a:p>
             <a:pPr indent="0" marL="0">
@@ -4892,7 +4920,21 @@
                   <a:srgbClr val="7F7F7F"/>
                 </a:solidFill>
               </a:rPr>
-              <a:t>예시. 실제 등급과 판정 기준은 위험관리 계획서(risk management plan)에 미리 정의함</a:t>
+              <a:t>제조사가 정하는 예시 방법이며, 등급·심각도 정의·판정 기준은 위험관리 계획서(risk management plan)에 미리 정의함</a:t>
+            </a:r>
+            <a:endParaRPr lang="en-US" sz="1100" dirty="0"/>
+          </a:p>
+          <a:p>
+            <a:pPr indent="0" marL="0">
+              <a:buNone/>
+            </a:pPr>
+            <a:r>
+              <a:rPr lang="en-US" sz="1100" dirty="0">
+                <a:solidFill>
+                  <a:srgbClr val="7F7F7F"/>
+                </a:solidFill>
+              </a:rPr>
+              <a:t>"허용" 칸도 가능한 한 위험을 줄일 의무와 잔여 위험 검토가 적용됨</a:t>
             </a:r>
             <a:endParaRPr lang="en-US" sz="1100" dirty="0"/>
           </a:p>
@@ -5024,11 +5066,11 @@
         <p:spPr>
           <a:xfrm>
             <a:off x="457200" y="1188720"/>
-            <a:ext cx="1005840" cy="914400"/>
+            <a:ext cx="1005840" cy="1051560"/>
           </a:xfrm>
           <a:prstGeom prst="roundRect">
             <a:avLst>
-              <a:gd name="adj" fmla="val 12000"/>
+              <a:gd name="adj" fmla="val 10909"/>
             </a:avLst>
           </a:prstGeom>
           <a:solidFill>
@@ -5068,11 +5110,11 @@
         <p:spPr>
           <a:xfrm>
             <a:off x="1600200" y="1188720"/>
-            <a:ext cx="10131552" cy="914400"/>
+            <a:ext cx="10131552" cy="1051560"/>
           </a:xfrm>
           <a:prstGeom prst="roundRect">
             <a:avLst>
-              <a:gd name="adj" fmla="val 12000"/>
+              <a:gd name="adj" fmla="val 10435"/>
             </a:avLst>
           </a:prstGeom>
           <a:solidFill>
@@ -5097,7 +5139,7 @@
                   <a:srgbClr val="262626"/>
                 </a:solidFill>
               </a:rPr>
-              <a:t>의도적 공격은 과거 데이터로 발생 확률을 추정하기 어렵다. 따라서 공격에 필요한 조건을 점수화한 공격 가능성(exploitability)으로 확률 축을 대신한다.</a:t>
+              <a:t>의도적 공격은 과거 데이터로 발생 확률을 추정하기 어렵다. 따라서 공격에 필요한 자원을 점수화하는 공인 방법으로 공격 가능성(exploitability)을 산정하고, 산정 근거를 계획서에 고정한다.</a:t>
             </a:r>
             <a:endParaRPr lang="en-US" sz="1600" dirty="0"/>
           </a:p>
@@ -5126,9 +5168,9 @@
             <a:tbl>
               <a:tblPr/>
               <a:tblGrid>
-                <a:gridCol w="3108960"/>
-                <a:gridCol w="1920240"/>
-                <a:gridCol w="1920240"/>
+                <a:gridCol w="3291840"/>
+                <a:gridCol w="1828800"/>
+                <a:gridCol w="1828800"/>
               </a:tblGrid>
               <a:tr h="512064">
                 <a:tc>
@@ -5554,7 +5596,7 @@
                           <a:ea typeface="Malgun Gothic" pitchFamily="34" charset="-122"/>
                           <a:cs typeface="Malgun Gothic" pitchFamily="34" charset="-120"/>
                         </a:rPr>
-                        <a:t>전문성(expertise)</a:t>
+                        <a:t>전문 기술 수준(specialist expertise)</a:t>
                       </a:r>
                       <a:endParaRPr lang="en-US" sz="1400" dirty="0">
                         <a:latin typeface="Malgun Gothic" charset="0"/>
@@ -5754,7 +5796,7 @@
                           <a:ea typeface="Malgun Gothic" pitchFamily="34" charset="-122"/>
                           <a:cs typeface="Malgun Gothic" pitchFamily="34" charset="-120"/>
                         </a:rPr>
-                        <a:t>제품 정보(knowledge of TOE)</a:t>
+                        <a:t>설계·운용 지식(knowledge of the TOE)</a:t>
                       </a:r>
                       <a:endParaRPr lang="en-US" sz="1400" dirty="0">
                         <a:latin typeface="Malgun Gothic" charset="0"/>
@@ -5887,7 +5929,7 @@
                           <a:ea typeface="Malgun Gothic" pitchFamily="34" charset="-122"/>
                           <a:cs typeface="Malgun Gothic" pitchFamily="34" charset="-120"/>
                         </a:rPr>
-                        <a:t>기밀 정보</a:t>
+                        <a:t>엄격히 통제된 정보</a:t>
                       </a:r>
                       <a:endParaRPr lang="en-US" sz="1400" dirty="0">
                         <a:latin typeface="Malgun Gothic" charset="0"/>
@@ -5954,7 +5996,7 @@
                           <a:ea typeface="Malgun Gothic" pitchFamily="34" charset="-122"/>
                           <a:cs typeface="Malgun Gothic" pitchFamily="34" charset="-120"/>
                         </a:rPr>
-                        <a:t>접근 기회(window of opportunity)</a:t>
+                        <a:t>기회의 창(window of opportunity)</a:t>
                       </a:r>
                       <a:endParaRPr lang="en-US" sz="1400" dirty="0">
                         <a:latin typeface="Malgun Gothic" charset="0"/>
@@ -6022,7 +6064,7 @@
                           <a:ea typeface="Malgun Gothic" pitchFamily="34" charset="-122"/>
                           <a:cs typeface="Malgun Gothic" pitchFamily="34" charset="-120"/>
                         </a:rPr>
-                        <a:t>원격·무제한</a:t>
+                        <a:t>제약 없음</a:t>
                       </a:r>
                       <a:endParaRPr lang="en-US" sz="1400" dirty="0">
                         <a:latin typeface="Malgun Gothic" charset="0"/>
@@ -6087,7 +6129,7 @@
                           <a:ea typeface="Malgun Gothic" pitchFamily="34" charset="-122"/>
                           <a:cs typeface="Malgun Gothic" pitchFamily="34" charset="-120"/>
                         </a:rPr>
-                        <a:t>물리적 접근·제한적</a:t>
+                        <a:t>매우 제한적</a:t>
                       </a:r>
                       <a:endParaRPr lang="en-US" sz="1400" dirty="0">
                         <a:latin typeface="Malgun Gothic" charset="0"/>
@@ -6349,7 +6391,7 @@
         <p:spPr>
           <a:xfrm>
             <a:off x="457200" y="5715000"/>
-            <a:ext cx="6949440" cy="320040"/>
+            <a:ext cx="6949440" cy="502920"/>
           </a:xfrm>
           <a:prstGeom prst="rect">
             <a:avLst/>
@@ -6358,7 +6400,7 @@
           <a:ln/>
         </p:spPr>
         <p:txBody>
-          <a:bodyPr wrap="square" lIns="0" tIns="0" rIns="0" bIns="0" rtlCol="0" anchor="ctr"/>
+          <a:bodyPr wrap="square" lIns="0" tIns="0" rIns="0" bIns="0" rtlCol="0" anchor="t"/>
           <a:lstStyle/>
           <a:p>
             <a:pPr indent="0" marL="0">
@@ -6370,7 +6412,7 @@
                   <a:srgbClr val="7F7F7F"/>
                 </a:solidFill>
               </a:rPr>
-              <a:t>근거: ISO/IEC 18045 공격 잠재력(attack potential) 산정 요소</a:t>
+              <a:t>근거: ISO/IEC 18045·CEM 공격 잠재력(attack potential) 요소. 적용 판본·점수표·등급 변환 기준은 계획서에 명시함</a:t>
             </a:r>
             <a:endParaRPr lang="en-US" sz="1100" dirty="0"/>
           </a:p>
@@ -6762,7 +6804,7 @@
                   <a:srgbClr val="262626"/>
                 </a:solidFill>
               </a:rPr>
-              <a:t>대안: CVSS</a:t>
+              <a:t>대안: CVSS v3.1</a:t>
             </a:r>
             <a:endParaRPr lang="en-US" sz="1300" dirty="0"/>
           </a:p>
@@ -6776,7 +6818,21 @@
                   <a:srgbClr val="262626"/>
                 </a:solidFill>
               </a:rPr>
-              <a:t>공격 가능성 지표(exploitability metrics)를 쓸 수 있음. 단, 환자 위해 심각도는 별도로 평가함</a:t>
+              <a:t>AV·AC·PR·UI 지표를 보조 입력으로 활용함</a:t>
+            </a:r>
+            <a:endParaRPr lang="en-US" sz="1300" dirty="0"/>
+          </a:p>
+          <a:p>
+            <a:pPr algn="l" indent="0" marL="0">
+              <a:buNone/>
+            </a:pPr>
+            <a:r>
+              <a:rPr lang="en-US" sz="1300" dirty="0">
+                <a:solidFill>
+                  <a:srgbClr val="262626"/>
+                </a:solidFill>
+              </a:rPr>
+              <a:t>환자 위해 심각도는 별도로 평가함</a:t>
             </a:r>
             <a:endParaRPr lang="en-US" sz="1300" dirty="0"/>
           </a:p>
@@ -6908,11 +6964,11 @@
         <p:spPr>
           <a:xfrm>
             <a:off x="457200" y="1188720"/>
-            <a:ext cx="1005840" cy="914400"/>
+            <a:ext cx="1005840" cy="1051560"/>
           </a:xfrm>
           <a:prstGeom prst="roundRect">
             <a:avLst>
-              <a:gd name="adj" fmla="val 12000"/>
+              <a:gd name="adj" fmla="val 10909"/>
             </a:avLst>
           </a:prstGeom>
           <a:solidFill>
@@ -6952,11 +7008,11 @@
         <p:spPr>
           <a:xfrm>
             <a:off x="1600200" y="1188720"/>
-            <a:ext cx="10131552" cy="914400"/>
+            <a:ext cx="10131552" cy="1051560"/>
           </a:xfrm>
           <a:prstGeom prst="roundRect">
             <a:avLst>
-              <a:gd name="adj" fmla="val 12000"/>
+              <a:gd name="adj" fmla="val 10435"/>
             </a:avLst>
           </a:prstGeom>
           <a:solidFill>
@@ -6981,7 +7037,7 @@
                   <a:srgbClr val="262626"/>
                 </a:solidFill>
               </a:rPr>
-              <a:t>확률 대신 "사전 기준 + 최악 가정 + 통제 효과 검증 + 시판 후 감시"를 하나의 논리로 묶어 잔여 위험(residual risk)이 허용 가능함을 보인다.</a:t>
+              <a:t>확률 대신 사전 기준, 최악의 임상 결과 가정, 통제 효과의 객관적 증거, 시판 후 감시를 하나의 논리로 묶어 잔여 위험(residual risk)이 허용 가능함을 보인다.</a:t>
             </a:r>
             <a:endParaRPr lang="en-US" sz="1600" dirty="0"/>
           </a:p>
@@ -6996,11 +7052,11 @@
         <p:spPr>
           <a:xfrm>
             <a:off x="457200" y="2514600"/>
-            <a:ext cx="2606040" cy="2194560"/>
+            <a:ext cx="2606040" cy="2468880"/>
           </a:xfrm>
           <a:prstGeom prst="roundRect">
             <a:avLst>
-              <a:gd name="adj" fmla="val 5000"/>
+              <a:gd name="adj" fmla="val 4444"/>
             </a:avLst>
           </a:prstGeom>
           <a:solidFill>
@@ -7107,8 +7163,8 @@
         </p:nvSpPr>
         <p:spPr>
           <a:xfrm>
-            <a:off x="640080" y="3383280"/>
-            <a:ext cx="2240280" cy="1188720"/>
+            <a:off x="640080" y="3337560"/>
+            <a:ext cx="2240280" cy="1554480"/>
           </a:xfrm>
           <a:prstGeom prst="rect">
             <a:avLst/>
@@ -7129,7 +7185,7 @@
                   <a:srgbClr val="262626"/>
                 </a:solidFill>
               </a:rPr>
-              <a:t>위험관리 계획서에 공격 가능성 등급, 매트릭스, 허용 기준을 평가 전에 정해 둠</a:t>
+              <a:t>공격 가능성 등급, 심각도 정의, 매트릭스, 허용 기준을 평가 전에 계획서에 정해 둠</a:t>
             </a:r>
             <a:endParaRPr lang="en-US" sz="1400" dirty="0"/>
           </a:p>
@@ -7143,7 +7199,7 @@
         </p:nvSpPr>
         <p:spPr>
           <a:xfrm>
-            <a:off x="3090672" y="3611880"/>
+            <a:off x="3090672" y="3749040"/>
             <a:ext cx="228600" cy="0"/>
           </a:xfrm>
           <a:prstGeom prst="line">
@@ -7168,11 +7224,11 @@
         <p:spPr>
           <a:xfrm>
             <a:off x="3346704" y="2514600"/>
-            <a:ext cx="2606040" cy="2194560"/>
+            <a:ext cx="2606040" cy="2468880"/>
           </a:xfrm>
           <a:prstGeom prst="roundRect">
             <a:avLst>
-              <a:gd name="adj" fmla="val 5000"/>
+              <a:gd name="adj" fmla="val 4444"/>
             </a:avLst>
           </a:prstGeom>
           <a:solidFill>
@@ -7265,7 +7321,7 @@
                   <a:srgbClr val="44546A"/>
                 </a:solidFill>
               </a:rPr>
-              <a:t>최악 가정</a:t>
+              <a:t>최악 결과 가정</a:t>
             </a:r>
             <a:endParaRPr lang="en-US" sz="1600" dirty="0"/>
           </a:p>
@@ -7279,8 +7335,8 @@
         </p:nvSpPr>
         <p:spPr>
           <a:xfrm>
-            <a:off x="3529584" y="3383280"/>
-            <a:ext cx="2240280" cy="1188720"/>
+            <a:off x="3529584" y="3337560"/>
+            <a:ext cx="2240280" cy="1554480"/>
           </a:xfrm>
           <a:prstGeom prst="rect">
             <a:avLst/>
@@ -7301,7 +7357,7 @@
                   <a:srgbClr val="262626"/>
                 </a:solidFill>
               </a:rPr>
-              <a:t>공격 가능성 평가 전에는 공격이 성공한다고 가정하고 위해 심각도를 평가함</a:t>
+              <a:t>공격이 성공한다고 보고, 합리적으로 예견 가능한 최악의 임상 결과와 가정을 기록함</a:t>
             </a:r>
             <a:endParaRPr lang="en-US" sz="1400" dirty="0"/>
           </a:p>
@@ -7315,7 +7371,7 @@
         </p:nvSpPr>
         <p:spPr>
           <a:xfrm>
-            <a:off x="5980176" y="3611880"/>
+            <a:off x="5980176" y="3749040"/>
             <a:ext cx="228600" cy="0"/>
           </a:xfrm>
           <a:prstGeom prst="line">
@@ -7340,11 +7396,11 @@
         <p:spPr>
           <a:xfrm>
             <a:off x="6236208" y="2514600"/>
-            <a:ext cx="2606040" cy="2194560"/>
+            <a:ext cx="2606040" cy="2468880"/>
           </a:xfrm>
           <a:prstGeom prst="roundRect">
             <a:avLst>
-              <a:gd name="adj" fmla="val 5000"/>
+              <a:gd name="adj" fmla="val 4444"/>
             </a:avLst>
           </a:prstGeom>
           <a:solidFill>
@@ -7451,8 +7507,8 @@
         </p:nvSpPr>
         <p:spPr>
           <a:xfrm>
-            <a:off x="6419088" y="3383280"/>
-            <a:ext cx="2240280" cy="1188720"/>
+            <a:off x="6419088" y="3337560"/>
+            <a:ext cx="2240280" cy="1554480"/>
           </a:xfrm>
           <a:prstGeom prst="rect">
             <a:avLst/>
@@ -7473,7 +7529,7 @@
                   <a:srgbClr val="262626"/>
                 </a:solidFill>
               </a:rPr>
-              <a:t>인증·암호화·무결성 검증 등 통제 적용 후 공격 가능성을 재평가하고 침투 시험(penetration testing)으로 확인함</a:t>
+              <a:t>요구사항 시험·설계 검토·취약점 분석·침투 시험(penetration testing)으로 확인하고 범위·한계를 명시함</a:t>
             </a:r>
             <a:endParaRPr lang="en-US" sz="1400" dirty="0"/>
           </a:p>
@@ -7487,7 +7543,7 @@
         </p:nvSpPr>
         <p:spPr>
           <a:xfrm>
-            <a:off x="8869680" y="3611880"/>
+            <a:off x="8869680" y="3749040"/>
             <a:ext cx="228600" cy="0"/>
           </a:xfrm>
           <a:prstGeom prst="line">
@@ -7512,11 +7568,11 @@
         <p:spPr>
           <a:xfrm>
             <a:off x="9125712" y="2514600"/>
-            <a:ext cx="2606040" cy="2194560"/>
+            <a:ext cx="2606040" cy="2468880"/>
           </a:xfrm>
           <a:prstGeom prst="roundRect">
             <a:avLst>
-              <a:gd name="adj" fmla="val 5000"/>
+              <a:gd name="adj" fmla="val 4444"/>
             </a:avLst>
           </a:prstGeom>
           <a:solidFill>
@@ -7623,8 +7679,8 @@
         </p:nvSpPr>
         <p:spPr>
           <a:xfrm>
-            <a:off x="9308592" y="3383280"/>
-            <a:ext cx="2240280" cy="1188720"/>
+            <a:off x="9308592" y="3337560"/>
+            <a:ext cx="2240280" cy="1554480"/>
           </a:xfrm>
           <a:prstGeom prst="rect">
             <a:avLst/>
@@ -7645,7 +7701,7 @@
                   <a:srgbClr val="262626"/>
                 </a:solidFill>
               </a:rPr>
-              <a:t>취약점 모니터링, SBOM(소프트웨어 자재 명세서), 패치 계획으로 변화를 추적하고 재평가함</a:t>
+              <a:t>SBOM(소프트웨어 자재 명세서)을 바탕으로 취약점을 모니터링하고 패치 계획에 따라 재평가함</a:t>
             </a:r>
             <a:endParaRPr lang="en-US" sz="1400" dirty="0"/>
           </a:p>
@@ -7659,12 +7715,12 @@
         </p:nvSpPr>
         <p:spPr>
           <a:xfrm>
-            <a:off x="457200" y="5029200"/>
-            <a:ext cx="11274552" cy="868680"/>
+            <a:off x="457200" y="5166360"/>
+            <a:ext cx="11274552" cy="960120"/>
           </a:xfrm>
           <a:prstGeom prst="roundRect">
             <a:avLst>
-              <a:gd name="adj" fmla="val 12632"/>
+              <a:gd name="adj" fmla="val 11429"/>
             </a:avLst>
           </a:prstGeom>
           <a:solidFill>
@@ -7700,7 +7756,7 @@
                   <a:srgbClr val="262626"/>
                 </a:solidFill>
               </a:rPr>
-              <a:t>잔여 위험이 허용 기준을 넘으면 추가 통제를 적용한다. 더 줄일 수 없는 개별 위험은 이익-위험 분석(benefit-risk analysis, ISO 14971:2019 7.4항)으로 판단하고, 전체 잔여 위험은 8항에 따라 평가한다.</a:t>
+              <a:t>기준을 넘으면 추가 통제를 적용한다. 추가 통제가 실행 가능하지 않은 개별 위험은 이익-위험 분석(benefit-risk analysis, ISO 14971:2019 7.4항)으로 판단하고, 이익을 입증하지 못하면 허용 불가로 남긴다. 전체 잔여 위험은 8항에 따라 평가한다.</a:t>
             </a:r>
             <a:endParaRPr lang="en-US" sz="1400" dirty="0"/>
           </a:p>

</xml_diff>